<commit_message>
docs: correct team name and university across submission artifacts
Esume -> Mia Braun, Drexel University -> Stevens Institute of Technology
in README, project report (md + pdf), and final presentations (v1 + v2).
</commit_message>
<xml_diff>
--- a/docs/BioLink_Final_Presentation_v2.pptx
+++ b/docs/BioLink_Final_Presentation_v2.pptx
@@ -3460,7 +3460,7 @@
               </a:defRPr>
             </a:pPr>
             <a:r>
-              <a:t>Esume</a:t>
+              <a:t>Mia Braun</a:t>
             </a:r>
           </a:p>
         </p:txBody>
@@ -3586,7 +3586,7 @@
               </a:defRPr>
             </a:pPr>
             <a:r>
-              <a:t>AAI 595 - Applied Machine Learning  |  Dr. Tao Han  |  Drexel University</a:t>
+              <a:t>AAI 595 - Applied Machine Learning  |  Dr. Tao Han  |  Stevens Institute of Technology</a:t>
             </a:r>
           </a:p>
         </p:txBody>
@@ -8421,7 +8421,7 @@
             </a:r>
             <a:br/>
             <a:r>
-              <a:t>Esume</a:t>
+              <a:t>Mia Braun</a:t>
             </a:r>
             <a:br/>
             <a:br/>
@@ -8430,7 +8430,7 @@
             </a:r>
             <a:br/>
             <a:r>
-              <a:t>DR. TAO HAN | DREXEL UNIVERSITY</a:t>
+              <a:t>DR. TAO HAN | STEVENS INSTITUTE OF TECHNOLOGY</a:t>
             </a:r>
           </a:p>
         </p:txBody>
@@ -9449,7 +9449,7 @@
               </a:defRPr>
             </a:pPr>
             <a:r>
-              <a:t>BIOLINK | AAI 595 | DREXEL UNIVERSITY</a:t>
+              <a:t>BIOLINK | AAI 595 | STEVENS INSTITUTE OF TECHNOLOGY</a:t>
             </a:r>
           </a:p>
         </p:txBody>
@@ -10303,7 +10303,7 @@
               </a:defRPr>
             </a:pPr>
             <a:r>
-              <a:t>BIOLINK | AAI 595 | DREXEL UNIVERSITY</a:t>
+              <a:t>BIOLINK | AAI 595 | STEVENS INSTITUTE OF TECHNOLOGY</a:t>
             </a:r>
           </a:p>
         </p:txBody>
@@ -11266,7 +11266,7 @@
               </a:defRPr>
             </a:pPr>
             <a:r>
-              <a:t>BIOLINK | AAI 595 | DREXEL UNIVERSITY</a:t>
+              <a:t>BIOLINK | AAI 595 | STEVENS INSTITUTE OF TECHNOLOGY</a:t>
             </a:r>
           </a:p>
         </p:txBody>

</xml_diff>